<commit_message>
docs: add mobile timeline to presentation
</commit_message>
<xml_diff>
--- a/docs/hackathon/slides/lifecompass-slides.pptx
+++ b/docs/hackathon/slides/lifecompass-slides.pptx
@@ -5162,7 +5162,7 @@
         <p:spPr>
           <a:xfrm>
             <a:off x="640080" y="1371600"/>
-            <a:ext cx="5212080" cy="2971800"/>
+            <a:ext cx="4023360" cy="2971800"/>
           </a:xfrm>
           <a:prstGeom prst="rect">
             <a:avLst/>
@@ -5176,7 +5176,7 @@
       </p:pic>
       <p:pic>
         <p:nvPicPr>
-          <p:cNvPr id="4" name="Picture 3" descr="event-detail-childbirth.jpg"/>
+          <p:cNvPr id="4" name="Picture 3" descr="timeline-mobile.jpg"/>
           <p:cNvPicPr>
             <a:picLocks noChangeAspect="1"/>
           </p:cNvPicPr>
@@ -5190,8 +5190,8 @@
         </p:blipFill>
         <p:spPr>
           <a:xfrm>
-            <a:off x="6035040" y="1371600"/>
-            <a:ext cx="5212080" cy="2971800"/>
+            <a:off x="4846320" y="1371600"/>
+            <a:ext cx="1371600" cy="2971800"/>
           </a:xfrm>
           <a:prstGeom prst="rect">
             <a:avLst/>
@@ -5203,9 +5203,38 @@
           </a:ln>
         </p:spPr>
       </p:pic>
-      <p:sp>
-        <p:nvSpPr>
-          <p:cNvPr id="5" name="TextBox 4"/>
+      <p:pic>
+        <p:nvPicPr>
+          <p:cNvPr id="5" name="Picture 4" descr="event-detail-childbirth.jpg"/>
+          <p:cNvPicPr>
+            <a:picLocks noChangeAspect="1"/>
+          </p:cNvPicPr>
+          <p:nvPr/>
+        </p:nvPicPr>
+        <p:blipFill>
+          <a:blip r:embed="rId4"/>
+          <a:stretch>
+            <a:fillRect/>
+          </a:stretch>
+        </p:blipFill>
+        <p:spPr>
+          <a:xfrm>
+            <a:off x="6400800" y="1371600"/>
+            <a:ext cx="4846320" cy="2971800"/>
+          </a:xfrm>
+          <a:prstGeom prst="rect">
+            <a:avLst/>
+          </a:prstGeom>
+          <a:ln w="12700">
+            <a:solidFill>
+              <a:srgbClr val="D9D0BC"/>
+            </a:solidFill>
+          </a:ln>
+        </p:spPr>
+      </p:pic>
+      <p:sp>
+        <p:nvSpPr>
+          <p:cNvPr id="6" name="TextBox 5"/>
           <p:cNvSpPr txBox="1"/>
           <p:nvPr/>
         </p:nvSpPr>
@@ -5262,7 +5291,7 @@
       </p:sp>
       <p:sp>
         <p:nvSpPr>
-          <p:cNvPr id="6" name="TextBox 5"/>
+          <p:cNvPr id="7" name="TextBox 6"/>
           <p:cNvSpPr txBox="1"/>
           <p:nvPr/>
         </p:nvSpPr>
@@ -5302,7 +5331,7 @@
       </p:sp>
       <p:sp>
         <p:nvSpPr>
-          <p:cNvPr id="7" name="TextBox 6"/>
+          <p:cNvPr id="8" name="TextBox 7"/>
           <p:cNvSpPr txBox="1"/>
           <p:nvPr/>
         </p:nvSpPr>
@@ -5342,7 +5371,7 @@
       </p:sp>
       <p:sp>
         <p:nvSpPr>
-          <p:cNvPr id="8" name="TextBox 7"/>
+          <p:cNvPr id="9" name="TextBox 8"/>
           <p:cNvSpPr txBox="1"/>
           <p:nvPr/>
         </p:nvSpPr>

</xml_diff>